<commit_message>
Re-derive OB and OEU Managed Service vs Integration/Resale split via sub-category decomposition
- Researched Orange's public disclosures: no official managed-service vs project split exists
  within the IT&Integration (3,698M€) line, so built a bottom-up estimate instead
- Decomposed IT&Integration into Cyberdefense/Cloud/Digital Workplace/Data&AI-Consulting/
  systems-integration sub-categories, applied industry-typical recurring ratios to each:
  ~44% of the 3,698M€ is genuinely recurring, ~56% is project-based
- OB overall: Managed Service ~5,246M€ (71.6%), Integration/Resale ~2,080M€ (28.4%),
  replacing Round 2's 49.5%/50.5% (which had treated the entire IT&Integration line as
  project-type)
- Applied the same logic to OEU for consistency: Managed Service ~2,210M€ (82%),
  Integration/Resale ~490M€ (18%), replacing the prior 74%/26%
- Cascaded the new totals through P02, P04, P06, P11, P13
</commit_message>
<xml_diff>
--- a/reference/Orange Business 三大区域B2B业务洞察 20260703.pptx
+++ b/reference/Orange Business 三大区域B2B业务洞察 20260703.pptx
@@ -6640,7 +6640,7 @@
                   <a:ea typeface="Microsoft YaHei"/>
                   <a:cs typeface="Arial"/>
                 </a:rPr>
-                <a:t>OB的3,698M€按行业招标分布高度分散</a:t>
+                <a:t>OB的2,080M€按行业招标分布高度分散</a:t>
               </a:r>
             </a:p>
           </p:txBody>
@@ -6745,7 +6745,7 @@
           <p:spPr>
             <a:xfrm>
               <a:off x="528066" y="953452"/>
-              <a:ext cx="5535356" cy="205359"/>
+              <a:ext cx="5686925" cy="205359"/>
             </a:xfrm>
             <a:prstGeom prst="rect">
               <a:avLst/>
@@ -6771,7 +6771,7 @@
                   <a:ea typeface="Microsoft YaHei"/>
                   <a:cs typeface="Arial"/>
                 </a:rPr>
-                <a:t>OB · 按行业招标类型的收入分布（估，总额3,698M€，官方IT&amp;Integration口径）</a:t>
+                <a:t>OB · 按行业招标类型的收入分布（估，总额2,080M€，IT&amp;Integration项目型部分）</a:t>
               </a:r>
             </a:p>
           </p:txBody>
@@ -7109,7 +7109,7 @@
                   <a:ea typeface="Arial"/>
                   <a:cs typeface="Arial"/>
                 </a:rPr>
-                <a:t>740</a:t>
+                <a:t>416</a:t>
               </a:r>
             </a:p>
           </p:txBody>
@@ -7269,7 +7269,7 @@
                   <a:ea typeface="Arial"/>
                   <a:cs typeface="Arial"/>
                 </a:rPr>
-                <a:t>666</a:t>
+                <a:t>374</a:t>
               </a:r>
             </a:p>
           </p:txBody>
@@ -7451,7 +7451,7 @@
                   <a:ea typeface="Arial"/>
                   <a:cs typeface="Arial"/>
                 </a:rPr>
-                <a:t>444</a:t>
+                <a:t>250</a:t>
               </a:r>
             </a:p>
           </p:txBody>
@@ -7611,7 +7611,7 @@
                   <a:ea typeface="Arial"/>
                   <a:cs typeface="Arial"/>
                 </a:rPr>
-                <a:t>370</a:t>
+                <a:t>208</a:t>
               </a:r>
             </a:p>
           </p:txBody>
@@ -7793,7 +7793,7 @@
                   <a:ea typeface="Arial"/>
                   <a:cs typeface="Arial"/>
                 </a:rPr>
-                <a:t>296</a:t>
+                <a:t>166</a:t>
               </a:r>
             </a:p>
           </p:txBody>
@@ -7953,7 +7953,7 @@
                   <a:ea typeface="Arial"/>
                   <a:cs typeface="Arial"/>
                 </a:rPr>
-                <a:t>296</a:t>
+                <a:t>166</a:t>
               </a:r>
             </a:p>
           </p:txBody>
@@ -8135,7 +8135,7 @@
                   <a:ea typeface="Arial"/>
                   <a:cs typeface="Arial"/>
                 </a:rPr>
-                <a:t>296</a:t>
+                <a:t>166</a:t>
               </a:r>
             </a:p>
           </p:txBody>
@@ -8295,7 +8295,7 @@
                   <a:ea typeface="Arial"/>
                   <a:cs typeface="Arial"/>
                 </a:rPr>
-                <a:t>259</a:t>
+                <a:t>146</a:t>
               </a:r>
             </a:p>
           </p:txBody>
@@ -8477,7 +8477,7 @@
                   <a:ea typeface="Arial"/>
                   <a:cs typeface="Arial"/>
                 </a:rPr>
-                <a:t>185</a:t>
+                <a:t>104</a:t>
               </a:r>
             </a:p>
           </p:txBody>
@@ -8610,8 +8610,8 @@
           </p:nvSpPr>
           <p:spPr>
             <a:xfrm>
-              <a:off x="3809562" y="4058602"/>
-              <a:ext cx="243897" cy="205359"/>
+              <a:off x="3887305" y="4058602"/>
+              <a:ext cx="166154" cy="205359"/>
             </a:xfrm>
             <a:prstGeom prst="rect">
               <a:avLst/>
@@ -8637,7 +8637,7 @@
                   <a:ea typeface="Arial"/>
                   <a:cs typeface="Arial"/>
                 </a:rPr>
-                <a:t>146</a:t>
+                <a:t>84</a:t>
               </a:r>
             </a:p>
           </p:txBody>
@@ -9438,7 +9438,7 @@
           <p:spPr>
             <a:xfrm>
               <a:off x="7462266" y="1315402"/>
-              <a:ext cx="2094128" cy="205359"/>
+              <a:ext cx="2542184" cy="205359"/>
             </a:xfrm>
             <a:prstGeom prst="rect">
               <a:avLst/>
@@ -9464,7 +9464,7 @@
                   <a:ea typeface="Microsoft YaHei"/>
                   <a:cs typeface="Arial"/>
                 </a:rPr>
-                <a:t>行业占比（估，总额约700M€）</a:t>
+                <a:t>行业占比（估，项目型总额约490M€）</a:t>
               </a:r>
             </a:p>
           </p:txBody>
@@ -9551,7 +9551,7 @@
                   <a:ea typeface="Arial"/>
                   <a:cs typeface="Arial"/>
                 </a:rPr>
-                <a:t xml:space="preserve"> — 35%/245M€</a:t>
+                <a:t xml:space="preserve"> — 35%/172M€</a:t>
               </a:r>
             </a:p>
           </p:txBody>
@@ -9565,7 +9565,7 @@
           <p:spPr>
             <a:xfrm>
               <a:off x="7462647" y="1856899"/>
-              <a:ext cx="2732044" cy="190690"/>
+              <a:ext cx="2658832" cy="190690"/>
             </a:xfrm>
             <a:prstGeom prst="rect">
               <a:avLst/>
@@ -9602,7 +9602,7 @@
                   <a:ea typeface="Arial"/>
                   <a:cs typeface="Arial"/>
                 </a:rPr>
-                <a:t xml:space="preserve"> — 20%/140M€</a:t>
+                <a:t xml:space="preserve"> — 20%/98M€</a:t>
               </a:r>
             </a:p>
           </p:txBody>
@@ -9616,7 +9616,7 @@
           <p:spPr>
             <a:xfrm>
               <a:off x="7462647" y="2066449"/>
-              <a:ext cx="2700048" cy="190690"/>
+              <a:ext cx="2626983" cy="190690"/>
             </a:xfrm>
             <a:prstGeom prst="rect">
               <a:avLst/>
@@ -9653,7 +9653,7 @@
                   <a:ea typeface="Arial"/>
                   <a:cs typeface="Arial"/>
                 </a:rPr>
-                <a:t xml:space="preserve"> — 15%/105M€</a:t>
+                <a:t xml:space="preserve"> — 15%/74M€</a:t>
               </a:r>
             </a:p>
           </p:txBody>
@@ -9667,7 +9667,7 @@
           <p:spPr>
             <a:xfrm>
               <a:off x="7462647" y="2275999"/>
-              <a:ext cx="2679573" cy="190690"/>
+              <a:ext cx="3234309" cy="190690"/>
             </a:xfrm>
             <a:prstGeom prst="rect">
               <a:avLst/>
@@ -9693,7 +9693,7 @@
                   <a:ea typeface="Microsoft YaHei"/>
                   <a:cs typeface="Arial"/>
                 </a:rPr>
-                <a:t>网络安全集成(罗马尼亚SCUT)</a:t>
+                <a:t>网络安全集成(罗马尼亚SCUT项目部分)</a:t>
               </a:r>
               <a:r>
                 <a:rPr lang="en-US" sz="980" dirty="0">
@@ -9704,7 +9704,7 @@
                   <a:ea typeface="Arial"/>
                   <a:cs typeface="Arial"/>
                 </a:rPr>
-                <a:t xml:space="preserve"> — 12%/84M€</a:t>
+                <a:t xml:space="preserve"> — 12%/59M€</a:t>
               </a:r>
             </a:p>
           </p:txBody>
@@ -9755,7 +9755,7 @@
                   <a:ea typeface="Arial"/>
                   <a:cs typeface="Arial"/>
                 </a:rPr>
-                <a:t xml:space="preserve"> — 10%/70M€</a:t>
+                <a:t xml:space="preserve"> — 10%/49M€</a:t>
               </a:r>
             </a:p>
           </p:txBody>
@@ -9806,7 +9806,7 @@
                   <a:ea typeface="Arial"/>
                   <a:cs typeface="Arial"/>
                 </a:rPr>
-                <a:t xml:space="preserve"> — 8%/56M€</a:t>
+                <a:t xml:space="preserve"> — 8%/38M€</a:t>
               </a:r>
             </a:p>
           </p:txBody>
@@ -13711,7 +13711,7 @@
                   <a:ea typeface="Microsoft YaHei"/>
                   <a:cs typeface="Arial"/>
                 </a:rPr>
-                <a:t>集成/转售(占比50.5%)</a:t>
+                <a:t>集成/转售(占比28.4%)</a:t>
               </a:r>
             </a:p>
           </p:txBody>
@@ -20886,7 +20886,7 @@
           <p:spPr>
             <a:xfrm>
               <a:off x="947738" y="3236595"/>
-              <a:ext cx="1784490" cy="176212"/>
+              <a:ext cx="1857185" cy="176212"/>
             </a:xfrm>
             <a:prstGeom prst="rect">
               <a:avLst/>
@@ -20912,7 +20912,7 @@
                   <a:ea typeface="Microsoft YaHei"/>
                   <a:cs typeface="Arial"/>
                 </a:rPr>
-                <a:t>管理服务3,627 · 集成转售3,698</a:t>
+                <a:t>管理服务72%·集成转售28%（估）</a:t>
               </a:r>
             </a:p>
           </p:txBody>
@@ -20926,7 +20926,7 @@
           <p:spPr>
             <a:xfrm>
               <a:off x="947738" y="3408045"/>
-              <a:ext cx="1093889" cy="176212"/>
+              <a:ext cx="1462507" cy="176212"/>
             </a:xfrm>
             <a:prstGeom prst="rect">
               <a:avLst/>
@@ -20952,7 +20952,7 @@
                   <a:ea typeface="Microsoft YaHei"/>
                   <a:cs typeface="Arial"/>
                 </a:rPr>
-                <a:t>固定2,715+移动912</a:t>
+                <a:t>固定2,715+移动912(M€)</a:t>
               </a:r>
             </a:p>
           </p:txBody>
@@ -20966,7 +20966,7 @@
           <p:spPr>
             <a:xfrm>
               <a:off x="947738" y="3579495"/>
-              <a:ext cx="1072058" cy="176212"/>
+              <a:ext cx="1221105" cy="176212"/>
             </a:xfrm>
             <a:prstGeom prst="rect">
               <a:avLst/>
@@ -20992,7 +20992,7 @@
                   <a:ea typeface="Microsoft YaHei"/>
                   <a:cs typeface="Arial"/>
                 </a:rPr>
-                <a:t>FY2025，实证数据</a:t>
+                <a:t>收入官方，拆分为估算</a:t>
               </a:r>
             </a:p>
           </p:txBody>
@@ -25140,7 +25140,7 @@
                   <a:ea typeface="Microsoft YaHei"/>
                   <a:cs typeface="Arial"/>
                 </a:rPr>
-                <a:t>OB · 存量深耕（集成/转售3,698M€）</a:t>
+                <a:t>OB · 存量深耕（集成/转售2,080M€）</a:t>
               </a:r>
             </a:p>
           </p:txBody>
@@ -25249,7 +25249,7 @@
                   <a:ea typeface="Arial"/>
                   <a:cs typeface="Arial"/>
                 </a:rPr>
-                <a:t>— 20%/740M€</a:t>
+                <a:t>— 20%/416M€</a:t>
               </a:r>
             </a:p>
           </p:txBody>
@@ -25322,7 +25322,7 @@
                   <a:ea typeface="Arial"/>
                   <a:cs typeface="Arial"/>
                 </a:rPr>
-                <a:t>— 18%/666M€</a:t>
+                <a:t>— 18%/374M€</a:t>
               </a:r>
             </a:p>
           </p:txBody>
@@ -25395,7 +25395,7 @@
                   <a:ea typeface="Arial"/>
                   <a:cs typeface="Arial"/>
                 </a:rPr>
-                <a:t>— 12%/444M€</a:t>
+                <a:t>— 12%/250M€</a:t>
               </a:r>
             </a:p>
           </p:txBody>
@@ -25468,7 +25468,7 @@
                   <a:ea typeface="Arial"/>
                   <a:cs typeface="Arial"/>
                 </a:rPr>
-                <a:t>— 10%/370M€</a:t>
+                <a:t>— 10%/208M€</a:t>
               </a:r>
             </a:p>
           </p:txBody>
@@ -25541,7 +25541,7 @@
                   <a:ea typeface="Arial"/>
                   <a:cs typeface="Arial"/>
                 </a:rPr>
-                <a:t>— 8%/296M€</a:t>
+                <a:t>— 8%/166M€</a:t>
               </a:r>
             </a:p>
           </p:txBody>
@@ -25614,7 +25614,7 @@
                   <a:ea typeface="Arial"/>
                   <a:cs typeface="Arial"/>
                 </a:rPr>
-                <a:t>— 8%/296M€</a:t>
+                <a:t>— 8%/166M€</a:t>
               </a:r>
             </a:p>
           </p:txBody>
@@ -25687,7 +25687,7 @@
                   <a:ea typeface="Arial"/>
                   <a:cs typeface="Arial"/>
                 </a:rPr>
-                <a:t>— 8%/296M€</a:t>
+                <a:t>— 8%/166M€</a:t>
               </a:r>
             </a:p>
           </p:txBody>
@@ -25760,7 +25760,7 @@
                   <a:ea typeface="Arial"/>
                   <a:cs typeface="Arial"/>
                 </a:rPr>
-                <a:t>— 7%/259M€</a:t>
+                <a:t>— 7%/146M€</a:t>
               </a:r>
             </a:p>
           </p:txBody>
@@ -31613,7 +31613,7 @@
           <p:spPr>
             <a:xfrm>
               <a:off x="521970" y="309562"/>
-              <a:ext cx="11112246" cy="440055"/>
+              <a:ext cx="11028236" cy="440055"/>
             </a:xfrm>
             <a:prstGeom prst="rect">
               <a:avLst/>
@@ -31639,7 +31639,7 @@
                   <a:ea typeface="Microsoft YaHei"/>
                   <a:cs typeface="Arial"/>
                 </a:rPr>
-                <a:t>OB管理服务与项目集成已近五五开——</a:t>
+                <a:t>OB仍以管理服务流水为主（72%），</a:t>
               </a:r>
               <a:r>
                 <a:rPr lang="zh-CN" sz="2250" b="1" dirty="0">
@@ -31789,7 +31789,7 @@
       </p:grpSp>
       <p:grpSp>
         <p:nvGrpSpPr>
-          <p:cNvPr id="26" name="Group 26"/>
+          <p:cNvPr id="27" name="Group 27"/>
           <p:cNvGrpSpPr/>
           <p:nvPr/>
         </p:nvGrpSpPr>
@@ -31922,7 +31922,7 @@
           <p:spPr>
             <a:xfrm>
               <a:off x="736092" y="1463992"/>
-              <a:ext cx="2889601" cy="264033"/>
+              <a:ext cx="3564885" cy="264033"/>
             </a:xfrm>
             <a:prstGeom prst="rect">
               <a:avLst/>
@@ -31948,7 +31948,7 @@
                   <a:ea typeface="Microsoft YaHei"/>
                   <a:cs typeface="Arial"/>
                 </a:rPr>
-                <a:t>Managed Service（连接类流水）</a:t>
+                <a:t>Managed Service（连接+经常性IT服务）</a:t>
               </a:r>
             </a:p>
           </p:txBody>
@@ -31962,7 +31962,7 @@
           <p:spPr>
             <a:xfrm>
               <a:off x="734568" y="1726882"/>
-              <a:ext cx="2493394" cy="322707"/>
+              <a:ext cx="1754101" cy="322707"/>
             </a:xfrm>
             <a:prstGeom prst="rect">
               <a:avLst/>
@@ -31988,7 +31988,7 @@
                   <a:ea typeface="Microsoft YaHei"/>
                   <a:cs typeface="Arial"/>
                 </a:rPr>
-                <a:t>3,627M€（官方口径）</a:t>
+                <a:t>5,246M€（估）</a:t>
               </a:r>
             </a:p>
           </p:txBody>
@@ -32002,7 +32002,7 @@
           <p:spPr>
             <a:xfrm>
               <a:off x="737997" y="2009299"/>
-              <a:ext cx="3282848" cy="190690"/>
+              <a:ext cx="3719703" cy="190690"/>
             </a:xfrm>
             <a:prstGeom prst="rect">
               <a:avLst/>
@@ -32028,7 +32028,7 @@
                   <a:ea typeface="Microsoft YaHei"/>
                   <a:cs typeface="Arial"/>
                 </a:rPr>
-                <a:t>占OB收入49.5%｜固定线路2,715+移动服务912(M€)</a:t>
+                <a:t>占OB收入71.6%｜固定2,715+移动912+IT经常性1,619(M€)</a:t>
               </a:r>
             </a:p>
           </p:txBody>
@@ -32042,7 +32042,7 @@
           <p:spPr>
             <a:xfrm>
               <a:off x="742950" y="2228850"/>
-              <a:ext cx="2143125" cy="95250"/>
+              <a:ext cx="1476375" cy="95250"/>
             </a:xfrm>
             <a:prstGeom prst="rect">
               <a:avLst/>
@@ -32063,8 +32063,8 @@
           </p:nvSpPr>
           <p:spPr>
             <a:xfrm>
-              <a:off x="2886075" y="2228850"/>
-              <a:ext cx="714375" cy="95250"/>
+              <a:off x="2219325" y="2228850"/>
+              <a:ext cx="495300" cy="95250"/>
             </a:xfrm>
             <a:prstGeom prst="rect">
               <a:avLst/>
@@ -32079,14 +32079,36 @@
         </p:sp>
         <p:sp>
           <p:nvSpPr>
-            <p:cNvPr id="18" name="TextBox 18"/>
+            <p:cNvPr id="18" name="Rectangle 18"/>
+            <p:cNvSpPr/>
+            <p:nvPr/>
+          </p:nvSpPr>
+          <p:spPr>
+            <a:xfrm>
+              <a:off x="2714625" y="2228850"/>
+              <a:ext cx="885825" cy="95250"/>
+            </a:xfrm>
+            <a:prstGeom prst="rect">
+              <a:avLst/>
+            </a:prstGeom>
+            <a:solidFill>
+              <a:srgbClr val="FFA640"/>
+            </a:solidFill>
+            <a:ln>
+              <a:noFill/>
+            </a:ln>
+          </p:spPr>
+        </p:sp>
+        <p:sp>
+          <p:nvSpPr>
+            <p:cNvPr id="19" name="TextBox 19"/>
             <p:cNvSpPr txBox="1"/>
             <p:nvPr/>
           </p:nvSpPr>
           <p:spPr>
             <a:xfrm>
               <a:off x="738188" y="2341245"/>
-              <a:ext cx="2444801" cy="176212"/>
+              <a:ext cx="2608250" cy="176212"/>
             </a:xfrm>
             <a:prstGeom prst="rect">
               <a:avLst/>
@@ -32112,14 +32134,14 @@
                   <a:ea typeface="Microsoft YaHei"/>
                   <a:cs typeface="Arial"/>
                 </a:rPr>
-                <a:t>固定线路75%(-7.6%) 移动服务25%(-6.1%)</a:t>
-              </a:r>
-            </a:p>
-          </p:txBody>
-        </p:sp>
-        <p:sp>
-          <p:nvSpPr>
-            <p:cNvPr id="19" name="Polygon 19"/>
+                <a:t>固定51.8% 移动17.4% IT经常性30.9%（估）</a:t>
+              </a:r>
+            </a:p>
+          </p:txBody>
+        </p:sp>
+        <p:sp>
+          <p:nvSpPr>
+            <p:cNvPr id="20" name="Polygon 20"/>
             <p:cNvSpPr/>
             <p:nvPr/>
           </p:nvSpPr>
@@ -32159,7 +32181,7 @@
         </p:sp>
         <p:sp>
           <p:nvSpPr>
-            <p:cNvPr id="20" name="Rectangle 20"/>
+            <p:cNvPr id="21" name="Rectangle 21"/>
             <p:cNvSpPr/>
             <p:nvPr/>
           </p:nvSpPr>
@@ -32185,7 +32207,7 @@
         </p:sp>
         <p:sp>
           <p:nvSpPr>
-            <p:cNvPr id="21" name="Rectangle 21"/>
+            <p:cNvPr id="22" name="Rectangle 22"/>
             <p:cNvSpPr/>
             <p:nvPr/>
           </p:nvSpPr>
@@ -32207,14 +32229,14 @@
         </p:sp>
         <p:sp>
           <p:nvSpPr>
-            <p:cNvPr id="22" name="TextBox 22"/>
+            <p:cNvPr id="23" name="TextBox 23"/>
             <p:cNvSpPr txBox="1"/>
             <p:nvPr/>
           </p:nvSpPr>
           <p:spPr>
             <a:xfrm>
               <a:off x="6393942" y="1463992"/>
-              <a:ext cx="2739478" cy="264033"/>
+              <a:ext cx="3203438" cy="264033"/>
             </a:xfrm>
             <a:prstGeom prst="rect">
               <a:avLst/>
@@ -32240,21 +32262,21 @@
                   <a:ea typeface="Microsoft YaHei"/>
                   <a:cs typeface="Arial"/>
                 </a:rPr>
-                <a:t>集成/转售（IT &amp; Integration）</a:t>
-              </a:r>
-            </a:p>
-          </p:txBody>
-        </p:sp>
-        <p:sp>
-          <p:nvSpPr>
-            <p:cNvPr id="23" name="TextBox 23"/>
+                <a:t>集成/转售（项目型IT&amp;Integration）</a:t>
+              </a:r>
+            </a:p>
+          </p:txBody>
+        </p:sp>
+        <p:sp>
+          <p:nvSpPr>
+            <p:cNvPr id="24" name="TextBox 24"/>
             <p:cNvSpPr txBox="1"/>
             <p:nvPr/>
           </p:nvSpPr>
           <p:spPr>
             <a:xfrm>
               <a:off x="6392418" y="1726882"/>
-              <a:ext cx="2493394" cy="322707"/>
+              <a:ext cx="1754101" cy="322707"/>
             </a:xfrm>
             <a:prstGeom prst="rect">
               <a:avLst/>
@@ -32280,14 +32302,14 @@
                   <a:ea typeface="Microsoft YaHei"/>
                   <a:cs typeface="Arial"/>
                 </a:rPr>
-                <a:t>3,698M€（官方口径）</a:t>
-              </a:r>
-            </a:p>
-          </p:txBody>
-        </p:sp>
-        <p:sp>
-          <p:nvSpPr>
-            <p:cNvPr id="24" name="TextBox 24"/>
+                <a:t>2,080M€（估）</a:t>
+              </a:r>
+            </a:p>
+          </p:txBody>
+        </p:sp>
+        <p:sp>
+          <p:nvSpPr>
+            <p:cNvPr id="25" name="TextBox 25"/>
             <p:cNvSpPr txBox="1"/>
             <p:nvPr/>
           </p:nvSpPr>
@@ -32320,21 +32342,21 @@
                   <a:ea typeface="Microsoft YaHei"/>
                   <a:cs typeface="Arial"/>
                 </a:rPr>
-                <a:t>占比50.5%｜国防20%+公共18%+医疗12%+其他50%（详见P11）</a:t>
-              </a:r>
-            </a:p>
-          </p:txBody>
-        </p:sp>
-        <p:sp>
-          <p:nvSpPr>
-            <p:cNvPr id="25" name="TextBox 25"/>
+                <a:t>占比28.4%｜国防20%+公共18%+医疗12%+其他50%（详见P11）</a:t>
+              </a:r>
+            </a:p>
+          </p:txBody>
+        </p:sp>
+        <p:sp>
+          <p:nvSpPr>
+            <p:cNvPr id="26" name="TextBox 26"/>
             <p:cNvSpPr txBox="1"/>
             <p:nvPr/>
           </p:nvSpPr>
           <p:spPr>
             <a:xfrm>
               <a:off x="6395847" y="2218849"/>
-              <a:ext cx="3891944" cy="190690"/>
+              <a:ext cx="3190953" cy="190690"/>
             </a:xfrm>
             <a:prstGeom prst="rect">
               <a:avLst/>
@@ -32360,7 +32382,7 @@
                   <a:ea typeface="Microsoft YaHei"/>
                   <a:cs typeface="Arial"/>
                 </a:rPr>
-                <a:t>含Cyberdefense安全1,300+Cloud650+系统集成/转售1,748(M€)</a:t>
+                <a:t>IT&amp;Integration官方3,698M€中约56%为项目型（估）</a:t>
               </a:r>
             </a:p>
           </p:txBody>
@@ -32368,7 +32390,7 @@
       </p:grpSp>
       <p:grpSp>
         <p:nvGrpSpPr>
-          <p:cNvPr id="29" name="Group 29"/>
+          <p:cNvPr id="30" name="Group 30"/>
           <p:cNvGrpSpPr/>
           <p:nvPr/>
         </p:nvGrpSpPr>
@@ -32382,7 +32404,7 @@
         </p:grpSpPr>
         <p:sp>
           <p:nvSpPr>
-            <p:cNvPr id="27" name="Rectangle 27"/>
+            <p:cNvPr id="28" name="Rectangle 28"/>
             <p:cNvSpPr/>
             <p:nvPr/>
           </p:nvSpPr>
@@ -32408,14 +32430,14 @@
         </p:sp>
         <p:sp>
           <p:nvSpPr>
-            <p:cNvPr id="28" name="TextBox 28"/>
+            <p:cNvPr id="29" name="TextBox 29"/>
             <p:cNvSpPr txBox="1"/>
             <p:nvPr/>
           </p:nvSpPr>
           <p:spPr>
             <a:xfrm>
               <a:off x="661797" y="2695099"/>
-              <a:ext cx="8909834" cy="190690"/>
+              <a:ext cx="8594229" cy="190690"/>
             </a:xfrm>
             <a:prstGeom prst="rect">
               <a:avLst/>
@@ -32441,7 +32463,7 @@
                   <a:ea typeface="Microsoft YaHei"/>
                   <a:cs typeface="Arial"/>
                 </a:rPr>
-                <a:t>口径说明：Orange官方"IT &amp; Integration"业务线以项目招标/系统集成交付为主，故归入集成/转售而非管理服务流水（已按OB确认口径修正）</a:t>
+                <a:t>口径说明：官方未公开该拆分；按Cyberdefense/Cloud/Workplace经常性收入占比估算，IT&amp;Integration中约44%为流水型、56%为项目型</a:t>
               </a:r>
             </a:p>
           </p:txBody>
@@ -32449,7 +32471,7 @@
       </p:grpSp>
       <p:grpSp>
         <p:nvGrpSpPr>
-          <p:cNvPr id="45" name="Group 45"/>
+          <p:cNvPr id="46" name="Group 46"/>
           <p:cNvGrpSpPr/>
           <p:nvPr/>
         </p:nvGrpSpPr>
@@ -32463,7 +32485,7 @@
         </p:grpSpPr>
         <p:sp>
           <p:nvSpPr>
-            <p:cNvPr id="30" name="Rectangle 30"/>
+            <p:cNvPr id="31" name="Rectangle 31"/>
             <p:cNvSpPr/>
             <p:nvPr/>
           </p:nvSpPr>
@@ -32487,7 +32509,7 @@
         </p:sp>
         <p:sp>
           <p:nvSpPr>
-            <p:cNvPr id="31" name="TextBox 31"/>
+            <p:cNvPr id="32" name="TextBox 32"/>
             <p:cNvSpPr txBox="1"/>
             <p:nvPr/>
           </p:nvSpPr>
@@ -32527,7 +32549,7 @@
         </p:sp>
         <p:sp>
           <p:nvSpPr>
-            <p:cNvPr id="32" name="Rectangle 32"/>
+            <p:cNvPr id="33" name="Rectangle 33"/>
             <p:cNvSpPr/>
             <p:nvPr/>
           </p:nvSpPr>
@@ -32553,7 +32575,7 @@
         </p:sp>
         <p:sp>
           <p:nvSpPr>
-            <p:cNvPr id="33" name="Rectangle 33"/>
+            <p:cNvPr id="34" name="Rectangle 34"/>
             <p:cNvSpPr/>
             <p:nvPr/>
           </p:nvSpPr>
@@ -32575,7 +32597,7 @@
         </p:sp>
         <p:sp>
           <p:nvSpPr>
-            <p:cNvPr id="34" name="TextBox 34"/>
+            <p:cNvPr id="35" name="TextBox 35"/>
             <p:cNvSpPr txBox="1"/>
             <p:nvPr/>
           </p:nvSpPr>
@@ -32615,14 +32637,14 @@
         </p:sp>
         <p:sp>
           <p:nvSpPr>
-            <p:cNvPr id="35" name="TextBox 35"/>
+            <p:cNvPr id="36" name="TextBox 36"/>
             <p:cNvSpPr txBox="1"/>
             <p:nvPr/>
           </p:nvSpPr>
           <p:spPr>
             <a:xfrm>
               <a:off x="734568" y="3727132"/>
-              <a:ext cx="2000532" cy="322707"/>
+              <a:ext cx="2702860" cy="322707"/>
             </a:xfrm>
             <a:prstGeom prst="rect">
               <a:avLst/>
@@ -32648,21 +32670,21 @@
                   <a:ea typeface="Microsoft YaHei"/>
                   <a:cs typeface="Arial"/>
                 </a:rPr>
-                <a:t>约2,000M€（估）</a:t>
-              </a:r>
-            </a:p>
-          </p:txBody>
-        </p:sp>
-        <p:sp>
-          <p:nvSpPr>
-            <p:cNvPr id="36" name="TextBox 36"/>
+                <a:t>约2,210M€（估，82%）</a:t>
+              </a:r>
+            </a:p>
+          </p:txBody>
+        </p:sp>
+        <p:sp>
+          <p:nvSpPr>
+            <p:cNvPr id="37" name="TextBox 37"/>
             <p:cNvSpPr txBox="1"/>
             <p:nvPr/>
           </p:nvSpPr>
           <p:spPr>
             <a:xfrm>
               <a:off x="737616" y="4001452"/>
-              <a:ext cx="2908363" cy="205359"/>
+              <a:ext cx="2796083" cy="205359"/>
             </a:xfrm>
             <a:prstGeom prst="rect">
               <a:avLst/>
@@ -32688,14 +32710,14 @@
                   <a:ea typeface="Microsoft YaHei"/>
                   <a:cs typeface="Arial"/>
                 </a:rPr>
-                <a:t>连接管理为主，占比约74%（估，27亿€基数）</a:t>
-              </a:r>
-            </a:p>
-          </p:txBody>
-        </p:sp>
-        <p:sp>
-          <p:nvSpPr>
-            <p:cNvPr id="37" name="TextBox 37"/>
+                <a:t>连接2,000+ICT经常性部分210（估，M€）</a:t>
+              </a:r>
+            </a:p>
+          </p:txBody>
+        </p:sp>
+        <p:sp>
+          <p:nvSpPr>
+            <p:cNvPr id="38" name="TextBox 38"/>
             <p:cNvSpPr txBox="1"/>
             <p:nvPr/>
           </p:nvSpPr>
@@ -32735,7 +32757,7 @@
         </p:sp>
         <p:sp>
           <p:nvSpPr>
-            <p:cNvPr id="38" name="Polygon 38"/>
+            <p:cNvPr id="39" name="Polygon 39"/>
             <p:cNvSpPr/>
             <p:nvPr/>
           </p:nvSpPr>
@@ -32775,7 +32797,7 @@
         </p:sp>
         <p:sp>
           <p:nvSpPr>
-            <p:cNvPr id="39" name="Rectangle 39"/>
+            <p:cNvPr id="40" name="Rectangle 40"/>
             <p:cNvSpPr/>
             <p:nvPr/>
           </p:nvSpPr>
@@ -32801,7 +32823,7 @@
         </p:sp>
         <p:sp>
           <p:nvSpPr>
-            <p:cNvPr id="40" name="Rectangle 40"/>
+            <p:cNvPr id="41" name="Rectangle 41"/>
             <p:cNvSpPr/>
             <p:nvPr/>
           </p:nvSpPr>
@@ -32823,7 +32845,7 @@
         </p:sp>
         <p:sp>
           <p:nvSpPr>
-            <p:cNvPr id="41" name="TextBox 41"/>
+            <p:cNvPr id="42" name="TextBox 42"/>
             <p:cNvSpPr txBox="1"/>
             <p:nvPr/>
           </p:nvSpPr>
@@ -32863,7 +32885,7 @@
         </p:sp>
         <p:sp>
           <p:nvSpPr>
-            <p:cNvPr id="42" name="TextBox 42"/>
+            <p:cNvPr id="43" name="TextBox 43"/>
             <p:cNvSpPr txBox="1"/>
             <p:nvPr/>
           </p:nvSpPr>
@@ -32896,14 +32918,14 @@
                   <a:ea typeface="Microsoft YaHei"/>
                   <a:cs typeface="Arial"/>
                 </a:rPr>
-                <a:t>约700M€（估，26%）</a:t>
-              </a:r>
-            </a:p>
-          </p:txBody>
-        </p:sp>
-        <p:sp>
-          <p:nvSpPr>
-            <p:cNvPr id="43" name="TextBox 43"/>
+                <a:t>约490M€（估，18%）</a:t>
+              </a:r>
+            </a:p>
+          </p:txBody>
+        </p:sp>
+        <p:sp>
+          <p:nvSpPr>
+            <p:cNvPr id="44" name="TextBox 44"/>
             <p:cNvSpPr txBox="1"/>
             <p:nvPr/>
           </p:nvSpPr>
@@ -32943,7 +32965,7 @@
         </p:sp>
         <p:sp>
           <p:nvSpPr>
-            <p:cNvPr id="44" name="TextBox 44"/>
+            <p:cNvPr id="45" name="TextBox 45"/>
             <p:cNvSpPr txBox="1"/>
             <p:nvPr/>
           </p:nvSpPr>
@@ -32984,7 +33006,7 @@
       </p:grpSp>
       <p:grpSp>
         <p:nvGrpSpPr>
-          <p:cNvPr id="61" name="Group 61"/>
+          <p:cNvPr id="62" name="Group 62"/>
           <p:cNvGrpSpPr/>
           <p:nvPr/>
         </p:nvGrpSpPr>
@@ -32998,7 +33020,7 @@
         </p:grpSpPr>
         <p:sp>
           <p:nvSpPr>
-            <p:cNvPr id="46" name="Rectangle 46"/>
+            <p:cNvPr id="47" name="Rectangle 47"/>
             <p:cNvSpPr/>
             <p:nvPr/>
           </p:nvSpPr>
@@ -33022,7 +33044,7 @@
         </p:sp>
         <p:sp>
           <p:nvSpPr>
-            <p:cNvPr id="47" name="TextBox 47"/>
+            <p:cNvPr id="48" name="TextBox 48"/>
             <p:cNvSpPr txBox="1"/>
             <p:nvPr/>
           </p:nvSpPr>
@@ -33062,7 +33084,7 @@
         </p:sp>
         <p:sp>
           <p:nvSpPr>
-            <p:cNvPr id="48" name="Rectangle 48"/>
+            <p:cNvPr id="49" name="Rectangle 49"/>
             <p:cNvSpPr/>
             <p:nvPr/>
           </p:nvSpPr>
@@ -33088,7 +33110,7 @@
         </p:sp>
         <p:sp>
           <p:nvSpPr>
-            <p:cNvPr id="49" name="Rectangle 49"/>
+            <p:cNvPr id="50" name="Rectangle 50"/>
             <p:cNvSpPr/>
             <p:nvPr/>
           </p:nvSpPr>
@@ -33110,7 +33132,7 @@
         </p:sp>
         <p:sp>
           <p:nvSpPr>
-            <p:cNvPr id="50" name="TextBox 50"/>
+            <p:cNvPr id="51" name="TextBox 51"/>
             <p:cNvSpPr txBox="1"/>
             <p:nvPr/>
           </p:nvSpPr>
@@ -33150,7 +33172,7 @@
         </p:sp>
         <p:sp>
           <p:nvSpPr>
-            <p:cNvPr id="51" name="TextBox 51"/>
+            <p:cNvPr id="52" name="TextBox 52"/>
             <p:cNvSpPr txBox="1"/>
             <p:nvPr/>
           </p:nvSpPr>
@@ -33190,7 +33212,7 @@
         </p:sp>
         <p:sp>
           <p:nvSpPr>
-            <p:cNvPr id="52" name="TextBox 52"/>
+            <p:cNvPr id="53" name="TextBox 53"/>
             <p:cNvSpPr txBox="1"/>
             <p:nvPr/>
           </p:nvSpPr>
@@ -33230,7 +33252,7 @@
         </p:sp>
         <p:sp>
           <p:nvSpPr>
-            <p:cNvPr id="53" name="TextBox 53"/>
+            <p:cNvPr id="54" name="TextBox 54"/>
             <p:cNvSpPr txBox="1"/>
             <p:nvPr/>
           </p:nvSpPr>
@@ -33270,7 +33292,7 @@
         </p:sp>
         <p:sp>
           <p:nvSpPr>
-            <p:cNvPr id="54" name="Polygon 54"/>
+            <p:cNvPr id="55" name="Polygon 55"/>
             <p:cNvSpPr/>
             <p:nvPr/>
           </p:nvSpPr>
@@ -33310,7 +33332,7 @@
         </p:sp>
         <p:sp>
           <p:nvSpPr>
-            <p:cNvPr id="55" name="Rectangle 55"/>
+            <p:cNvPr id="56" name="Rectangle 56"/>
             <p:cNvSpPr/>
             <p:nvPr/>
           </p:nvSpPr>
@@ -33336,7 +33358,7 @@
         </p:sp>
         <p:sp>
           <p:nvSpPr>
-            <p:cNvPr id="56" name="Rectangle 56"/>
+            <p:cNvPr id="57" name="Rectangle 57"/>
             <p:cNvSpPr/>
             <p:nvPr/>
           </p:nvSpPr>
@@ -33358,7 +33380,7 @@
         </p:sp>
         <p:sp>
           <p:nvSpPr>
-            <p:cNvPr id="57" name="TextBox 57"/>
+            <p:cNvPr id="58" name="TextBox 58"/>
             <p:cNvSpPr txBox="1"/>
             <p:nvPr/>
           </p:nvSpPr>
@@ -33398,7 +33420,7 @@
         </p:sp>
         <p:sp>
           <p:nvSpPr>
-            <p:cNvPr id="58" name="TextBox 58"/>
+            <p:cNvPr id="59" name="TextBox 59"/>
             <p:cNvSpPr txBox="1"/>
             <p:nvPr/>
           </p:nvSpPr>
@@ -33438,7 +33460,7 @@
         </p:sp>
         <p:sp>
           <p:nvSpPr>
-            <p:cNvPr id="59" name="TextBox 59"/>
+            <p:cNvPr id="60" name="TextBox 60"/>
             <p:cNvSpPr txBox="1"/>
             <p:nvPr/>
           </p:nvSpPr>
@@ -33478,7 +33500,7 @@
         </p:sp>
         <p:sp>
           <p:nvSpPr>
-            <p:cNvPr id="60" name="TextBox 60"/>
+            <p:cNvPr id="61" name="TextBox 61"/>
             <p:cNvSpPr txBox="1"/>
             <p:nvPr/>
           </p:nvSpPr>
@@ -33519,7 +33541,7 @@
       </p:grpSp>
       <p:grpSp>
         <p:nvGrpSpPr>
-          <p:cNvPr id="64" name="Group 64"/>
+          <p:cNvPr id="65" name="Group 65"/>
           <p:cNvGrpSpPr/>
           <p:nvPr/>
         </p:nvGrpSpPr>
@@ -33533,7 +33555,7 @@
         </p:grpSpPr>
         <p:sp>
           <p:nvSpPr>
-            <p:cNvPr id="62" name="TextBox 62"/>
+            <p:cNvPr id="63" name="TextBox 63"/>
             <p:cNvSpPr txBox="1"/>
             <p:nvPr/>
           </p:nvSpPr>
@@ -33573,7 +33595,7 @@
         </p:sp>
         <p:sp>
           <p:nvSpPr>
-            <p:cNvPr id="63" name="TextBox 63"/>
+            <p:cNvPr id="64" name="TextBox 64"/>
             <p:cNvSpPr txBox="1"/>
             <p:nvPr/>
           </p:nvSpPr>

</xml_diff>